<commit_message>
Added bonus notebook about time series decomposition.
</commit_message>
<xml_diff>
--- a/W5/1. W5S1 final/W5S1.pptx
+++ b/W5/1. W5S1 final/W5S1.pptx
@@ -277,7 +277,7 @@
 <file path=ppt/revisionInfo.xml><?xml version="1.0" encoding="utf-8"?>
 <p1510:revInfo xmlns:a="http://schemas.openxmlformats.org/drawingml/2006/main" xmlns:r="http://schemas.openxmlformats.org/officeDocument/2006/relationships" xmlns:p1510="http://schemas.microsoft.com/office/powerpoint/2015/10/main">
   <p1510:revLst>
-    <p1510:client id="{FF5E96C2-CAD4-4467-9AE0-F3D89E678849}" v="1" dt="2026-01-06T03:43:54.783"/>
+    <p1510:client id="{FF5E96C2-CAD4-4467-9AE0-F3D89E678849}" v="4" dt="2026-01-06T04:47:15.759"/>
   </p1510:revLst>
 </p1510:revInfo>
 </file>
@@ -287,24 +287,48 @@
   <pc:docChgLst>
     <pc:chgData name="Matthieu De Mari" userId="dfb708c9-d8dc-439f-9a3b-c772bf4a311c" providerId="ADAL" clId="{81E9B007-0C2C-493E-9B93-55A62C9C1F12}"/>
     <pc:docChg chg="custSel addSld modSld">
-      <pc:chgData name="Matthieu De Mari" userId="dfb708c9-d8dc-439f-9a3b-c772bf4a311c" providerId="ADAL" clId="{81E9B007-0C2C-493E-9B93-55A62C9C1F12}" dt="2026-01-06T03:45:07.009" v="303" actId="20577"/>
+      <pc:chgData name="Matthieu De Mari" userId="dfb708c9-d8dc-439f-9a3b-c772bf4a311c" providerId="ADAL" clId="{81E9B007-0C2C-493E-9B93-55A62C9C1F12}" dt="2026-01-06T04:47:34.642" v="359" actId="14100"/>
       <pc:docMkLst>
         <pc:docMk/>
       </pc:docMkLst>
-      <pc:sldChg chg="modSp add mod">
-        <pc:chgData name="Matthieu De Mari" userId="dfb708c9-d8dc-439f-9a3b-c772bf4a311c" providerId="ADAL" clId="{81E9B007-0C2C-493E-9B93-55A62C9C1F12}" dt="2026-01-06T03:45:07.009" v="303" actId="20577"/>
+      <pc:sldChg chg="addSp delSp modSp add mod chgLayout">
+        <pc:chgData name="Matthieu De Mari" userId="dfb708c9-d8dc-439f-9a3b-c772bf4a311c" providerId="ADAL" clId="{81E9B007-0C2C-493E-9B93-55A62C9C1F12}" dt="2026-01-06T04:47:34.642" v="359" actId="14100"/>
         <pc:sldMkLst>
           <pc:docMk/>
           <pc:sldMk cId="559955036" sldId="672"/>
         </pc:sldMkLst>
-        <pc:spChg chg="mod">
-          <ac:chgData name="Matthieu De Mari" userId="dfb708c9-d8dc-439f-9a3b-c772bf4a311c" providerId="ADAL" clId="{81E9B007-0C2C-493E-9B93-55A62C9C1F12}" dt="2026-01-06T03:45:07.009" v="303" actId="20577"/>
+        <pc:spChg chg="add mod ord">
+          <ac:chgData name="Matthieu De Mari" userId="dfb708c9-d8dc-439f-9a3b-c772bf4a311c" providerId="ADAL" clId="{81E9B007-0C2C-493E-9B93-55A62C9C1F12}" dt="2026-01-06T04:47:34.642" v="359" actId="14100"/>
+          <ac:spMkLst>
+            <pc:docMk/>
+            <pc:sldMk cId="559955036" sldId="672"/>
+            <ac:spMk id="2" creationId="{D7B27C08-981B-D29E-667C-0CA05F528EE4}"/>
+          </ac:spMkLst>
+        </pc:spChg>
+        <pc:spChg chg="mod ord">
+          <ac:chgData name="Matthieu De Mari" userId="dfb708c9-d8dc-439f-9a3b-c772bf4a311c" providerId="ADAL" clId="{81E9B007-0C2C-493E-9B93-55A62C9C1F12}" dt="2026-01-06T04:45:27.906" v="305" actId="700"/>
+          <ac:spMkLst>
+            <pc:docMk/>
+            <pc:sldMk cId="559955036" sldId="672"/>
+            <ac:spMk id="5" creationId="{2FA62BAB-0365-E25F-E7AA-0B21849DE445}"/>
+          </ac:spMkLst>
+        </pc:spChg>
+        <pc:spChg chg="mod ord">
+          <ac:chgData name="Matthieu De Mari" userId="dfb708c9-d8dc-439f-9a3b-c772bf4a311c" providerId="ADAL" clId="{81E9B007-0C2C-493E-9B93-55A62C9C1F12}" dt="2026-01-06T04:47:28.169" v="356" actId="12"/>
           <ac:spMkLst>
             <pc:docMk/>
             <pc:sldMk cId="559955036" sldId="672"/>
             <ac:spMk id="6" creationId="{A3CE3216-BB60-B2EA-0A77-7CD1D1669BBE}"/>
           </ac:spMkLst>
         </pc:spChg>
+        <pc:picChg chg="del">
+          <ac:chgData name="Matthieu De Mari" userId="dfb708c9-d8dc-439f-9a3b-c772bf4a311c" providerId="ADAL" clId="{81E9B007-0C2C-493E-9B93-55A62C9C1F12}" dt="2026-01-06T04:45:24.743" v="304" actId="478"/>
+          <ac:picMkLst>
+            <pc:docMk/>
+            <pc:sldMk cId="559955036" sldId="672"/>
+            <ac:picMk id="3" creationId="{2FBCE472-B101-706E-49C1-78BEAA685A6A}"/>
+          </ac:picMkLst>
+        </pc:picChg>
       </pc:sldChg>
     </pc:docChg>
   </pc:docChgLst>
@@ -4391,7 +4415,7 @@
         <p:spPr>
           <a:xfrm>
             <a:off x="838200" y="1825624"/>
-            <a:ext cx="4256314" cy="5032375"/>
+            <a:ext cx="5181600" cy="5032375"/>
           </a:xfrm>
         </p:spPr>
         <p:txBody>
@@ -4409,8 +4433,73 @@
             </a:r>
             <a:r>
               <a:rPr lang="en-GB" dirty="0"/>
-              <a:t>is technically out-of-scope for 50.039 DL, but it can give great insights about your data set before you dive into training AI models.</a:t>
-            </a:r>
+              <a:t>is technically out-of-scope for 50.039 DL, but it can give great insights about your dataset before you dive into training AI models.</a:t>
+            </a:r>
+          </a:p>
+          <a:p>
+            <a:r>
+              <a:rPr lang="en-GB" dirty="0"/>
+              <a:t>Time series decomposition helps uncover underlying patterns, like trend and seasonality, before training an AI model, allowing you to assess whether meaningful structure exists in the data.</a:t>
+            </a:r>
+          </a:p>
+        </p:txBody>
+      </p:sp>
+      <p:sp>
+        <p:nvSpPr>
+          <p:cNvPr id="2" name="Content Placeholder 1">
+            <a:extLst>
+              <a:ext uri="{FF2B5EF4-FFF2-40B4-BE49-F238E27FC236}">
+                <a16:creationId xmlns:a16="http://schemas.microsoft.com/office/drawing/2014/main" id="{D7B27C08-981B-D29E-667C-0CA05F528EE4}"/>
+              </a:ext>
+            </a:extLst>
+          </p:cNvPr>
+          <p:cNvSpPr>
+            <a:spLocks noGrp="1"/>
+          </p:cNvSpPr>
+          <p:nvPr>
+            <p:ph sz="half" idx="2"/>
+          </p:nvPr>
+        </p:nvSpPr>
+        <p:spPr>
+          <a:xfrm>
+            <a:off x="6172199" y="1825624"/>
+            <a:ext cx="5452353" cy="5032375"/>
+          </a:xfrm>
+        </p:spPr>
+        <p:txBody>
+          <a:bodyPr>
+            <a:normAutofit/>
+          </a:bodyPr>
+          <a:lstStyle/>
+          <a:p>
+            <a:r>
+              <a:rPr lang="en-GB" dirty="0"/>
+              <a:t>This insight can guide model selection, feature engineering, and preprocessing decisions, such as detrending or </a:t>
+            </a:r>
+            <a:r>
+              <a:rPr lang="en-GB" dirty="0" err="1"/>
+              <a:t>deseasonalizing</a:t>
+            </a:r>
+            <a:r>
+              <a:rPr lang="en-GB" dirty="0"/>
+              <a:t>. </a:t>
+            </a:r>
+          </a:p>
+          <a:p>
+            <a:r>
+              <a:rPr lang="en-GB" dirty="0"/>
+              <a:t>It also helps ensure the model focuses on learnable signals rather than unpredictable noise.</a:t>
+            </a:r>
+          </a:p>
+          <a:p>
+            <a:pPr marL="0" indent="0">
+              <a:buNone/>
+            </a:pPr>
+            <a:r>
+              <a:rPr lang="en-GB" dirty="0"/>
+              <a:t>We attach to these lecture slides an additional “bonus” notebook, which briefly introducing these concepts.</a:t>
+            </a:r>
+            <a:endParaRPr lang="en-SG" dirty="0"/>
           </a:p>
           <a:p>
             <a:pPr marL="0" indent="0">
@@ -4418,62 +4507,8 @@
             </a:pPr>
             <a:endParaRPr lang="en-GB" dirty="0"/>
           </a:p>
-          <a:p>
-            <a:pPr marL="0" indent="0">
-              <a:buNone/>
-            </a:pPr>
-            <a:r>
-              <a:rPr lang="en-GB" dirty="0"/>
-              <a:t>We attach to these lecture slides an additional “bonus” notebook</a:t>
-            </a:r>
-            <a:r>
-              <a:rPr lang="en-GB"/>
-              <a:t>, which briefly </a:t>
-            </a:r>
-            <a:r>
-              <a:rPr lang="en-GB" dirty="0"/>
-              <a:t>introducing these concepts.</a:t>
-            </a:r>
-            <a:endParaRPr lang="en-SG" dirty="0"/>
-          </a:p>
         </p:txBody>
       </p:sp>
-      <p:pic>
-        <p:nvPicPr>
-          <p:cNvPr id="3" name="Picture 2" descr="Chart, line chart&#10;&#10;Description automatically generated">
-            <a:extLst>
-              <a:ext uri="{FF2B5EF4-FFF2-40B4-BE49-F238E27FC236}">
-                <a16:creationId xmlns:a16="http://schemas.microsoft.com/office/drawing/2014/main" id="{2FBCE472-B101-706E-49C1-78BEAA685A6A}"/>
-              </a:ext>
-            </a:extLst>
-          </p:cNvPr>
-          <p:cNvPicPr>
-            <a:picLocks noChangeAspect="1"/>
-          </p:cNvPicPr>
-          <p:nvPr/>
-        </p:nvPicPr>
-        <p:blipFill>
-          <a:blip r:embed="rId2">
-            <a:extLst>
-              <a:ext uri="{28A0092B-C50C-407E-A947-70E740481C1C}">
-                <a14:useLocalDpi xmlns:a14="http://schemas.microsoft.com/office/drawing/2010/main" val="0"/>
-              </a:ext>
-            </a:extLst>
-          </a:blip>
-          <a:stretch>
-            <a:fillRect/>
-          </a:stretch>
-        </p:blipFill>
-        <p:spPr>
-          <a:xfrm>
-            <a:off x="5383763" y="1499053"/>
-            <a:ext cx="6808237" cy="5106178"/>
-          </a:xfrm>
-          <a:prstGeom prst="rect">
-            <a:avLst/>
-          </a:prstGeom>
-        </p:spPr>
-      </p:pic>
     </p:spTree>
     <p:extLst>
       <p:ext uri="{BB962C8B-B14F-4D97-AF65-F5344CB8AC3E}">

</xml_diff>